<commit_message>
README, deck refresh for the private pack, and submission.json = v4
Deck slide 2 now reports the private Evaluation pack instead of the retired
practice score, with MEASURED/PROJECTED constants at the top so a regenerate
after the next upload is one edit. Geometric QA clean, 90 shapes, 0 out of
bounds. CLAUDE.md's no-best-of rule corrected: the arena keeps every upload and
scores the best run, so experimental uploads are free.

Co-Authored-By: Claude Opus 5 <noreply@anthropic.com>
Claude-Session: https://claude.ai/code/session_01Kgf5cSk937pQSJ6ZH8TQRH
</commit_message>
<xml_diff>
--- a/deck/AHC_VAD_submission.pptx
+++ b/deck/AHC_VAD_submission.pptx
@@ -591,7 +591,7 @@
           <a:p>
             <a:r>
               <a:rPr lang="en-US" dirty="0"/>
-              <a:t>47.0/100 on the public arena. Biggest remaining pool is D3 at 11.5 of 40 across only four videos. Negative results are reported deliberately: the zero-shot VLM and the organisers' label correction both measurably hurt, and we kept what the measurements supported rather than what we expected.</a:t>
+              <a:t>Standing private-set score 37.2/100. The three fixes are candidate widths matched to the IoU 0.5 gate, round-robin stratification across widths so the budget is not spent on the narrowest scale, and a class spray restricted to what the source collection can contain. Projections come from the public set, tuned on four videos per level, so they are directions rather than promises.</a:t>
             </a:r>
             <a:endParaRPr lang="en-US" dirty="0"/>
           </a:p>
@@ -2763,7 +2763,7 @@
                 <a:ea typeface="Cambria" pitchFamily="34" charset="-122"/>
                 <a:cs typeface="Cambria" pitchFamily="34" charset="-120"/>
               </a:rPr>
-              <a:t>Result: 47.0 / 100 — and four experiments that failed</a:t>
+              <a:t>Private set: 37.2 measured, 53.8 projected after three fixes</a:t>
             </a:r>
             <a:endParaRPr lang="en-US" sz="2700" dirty="0"/>
           </a:p>
@@ -2802,7 +2802,7 @@
                 <a:ea typeface="Calibri" pitchFamily="34" charset="-122"/>
                 <a:cs typeface="Calibri" pitchFamily="34" charset="-120"/>
               </a:rPr>
-              <a:t>Public arena run. Every number below is measured, not estimated.</a:t>
+              <a:t>Every number is measured on the public set or deduced from upload deltas. Projections are labelled as such.</a:t>
             </a:r>
             <a:endParaRPr lang="en-US" sz="1300" dirty="0"/>
           </a:p>
@@ -2817,11 +2817,11 @@
         <p:spPr>
           <a:xfrm>
             <a:off x="502920" y="1280160"/>
-            <a:ext cx="2578608" cy="1170432"/>
+            <a:ext cx="2578608" cy="1298448"/>
           </a:xfrm>
           <a:prstGeom prst="roundRect">
             <a:avLst>
-              <a:gd name="adj" fmla="val 4688"/>
+              <a:gd name="adj" fmla="val 4225"/>
             </a:avLst>
           </a:prstGeom>
           <a:solidFill>
@@ -2843,7 +2843,7 @@
         </p:nvSpPr>
         <p:spPr>
           <a:xfrm>
-            <a:off x="667512" y="1408176"/>
+            <a:off x="667512" y="1389888"/>
             <a:ext cx="2249424" cy="237744"/>
           </a:xfrm>
           <a:prstGeom prst="rect">
@@ -2882,8 +2882,8 @@
         </p:nvSpPr>
         <p:spPr>
           <a:xfrm>
-            <a:off x="667512" y="1737360"/>
-            <a:ext cx="2249424" cy="548640"/>
+            <a:off x="667512" y="1682496"/>
+            <a:ext cx="2249424" cy="512064"/>
           </a:xfrm>
           <a:prstGeom prst="rect">
             <a:avLst/>
@@ -2907,7 +2907,7 @@
                 <a:ea typeface="Cambria" pitchFamily="34" charset="-122"/>
                 <a:cs typeface="Cambria" pitchFamily="34" charset="-120"/>
               </a:rPr>
-              <a:t>12.9</a:t>
+              <a:t>12.0</a:t>
             </a:r>
             <a:pPr indent="0" marL="0">
               <a:buNone/>
@@ -2929,18 +2929,57 @@
       </p:sp>
       <p:sp>
         <p:nvSpPr>
-          <p:cNvPr id="7" name="Shape 5"/>
+          <p:cNvPr id="7" name="Text 5"/>
+          <p:cNvSpPr/>
+          <p:nvPr/>
+        </p:nvSpPr>
+        <p:spPr>
+          <a:xfrm>
+            <a:off x="667512" y="2231136"/>
+            <a:ext cx="2249424" cy="237744"/>
+          </a:xfrm>
+          <a:prstGeom prst="rect">
+            <a:avLst/>
+          </a:prstGeom>
+          <a:noFill/>
+          <a:ln/>
+        </p:spPr>
+        <p:txBody>
+          <a:bodyPr wrap="square" lIns="0" tIns="0" rIns="0" bIns="0" rtlCol="0" anchor="ctr"/>
+          <a:lstStyle/>
+          <a:p>
+            <a:pPr indent="0" marL="0">
+              <a:buNone/>
+            </a:pPr>
+            <a:r>
+              <a:rPr lang="en-US" sz="1000" dirty="0">
+                <a:solidFill>
+                  <a:srgbClr val="5FCB8E"/>
+                </a:solidFill>
+                <a:latin typeface="Calibri" pitchFamily="34" charset="0"/>
+                <a:ea typeface="Calibri" pitchFamily="34" charset="-122"/>
+                <a:cs typeface="Calibri" pitchFamily="34" charset="-120"/>
+              </a:rPr>
+              <a:t>projected  15.0</a:t>
+            </a:r>
+            <a:endParaRPr lang="en-US" sz="1000" dirty="0"/>
+          </a:p>
+        </p:txBody>
+      </p:sp>
+      <p:sp>
+        <p:nvSpPr>
+          <p:cNvPr id="8" name="Shape 6"/>
           <p:cNvSpPr/>
           <p:nvPr/>
         </p:nvSpPr>
         <p:spPr>
           <a:xfrm>
             <a:off x="3364992" y="1280160"/>
-            <a:ext cx="2578608" cy="1170432"/>
+            <a:ext cx="2578608" cy="1298448"/>
           </a:xfrm>
           <a:prstGeom prst="roundRect">
             <a:avLst>
-              <a:gd name="adj" fmla="val 4688"/>
+              <a:gd name="adj" fmla="val 4225"/>
             </a:avLst>
           </a:prstGeom>
           <a:solidFill>
@@ -2956,13 +2995,13 @@
       </p:sp>
       <p:sp>
         <p:nvSpPr>
-          <p:cNvPr id="8" name="Text 6"/>
-          <p:cNvSpPr/>
-          <p:nvPr/>
-        </p:nvSpPr>
-        <p:spPr>
-          <a:xfrm>
-            <a:off x="3529584" y="1408176"/>
+          <p:cNvPr id="9" name="Text 7"/>
+          <p:cNvSpPr/>
+          <p:nvPr/>
+        </p:nvSpPr>
+        <p:spPr>
+          <a:xfrm>
+            <a:off x="3529584" y="1389888"/>
             <a:ext cx="2249424" cy="237744"/>
           </a:xfrm>
           <a:prstGeom prst="rect">
@@ -2995,14 +3034,14 @@
       </p:sp>
       <p:sp>
         <p:nvSpPr>
-          <p:cNvPr id="9" name="Text 7"/>
-          <p:cNvSpPr/>
-          <p:nvPr/>
-        </p:nvSpPr>
-        <p:spPr>
-          <a:xfrm>
-            <a:off x="3529584" y="1737360"/>
-            <a:ext cx="2249424" cy="548640"/>
+          <p:cNvPr id="10" name="Text 8"/>
+          <p:cNvSpPr/>
+          <p:nvPr/>
+        </p:nvSpPr>
+        <p:spPr>
+          <a:xfrm>
+            <a:off x="3529584" y="1682496"/>
+            <a:ext cx="2249424" cy="512064"/>
           </a:xfrm>
           <a:prstGeom prst="rect">
             <a:avLst/>
@@ -3026,7 +3065,7 @@
                 <a:ea typeface="Cambria" pitchFamily="34" charset="-122"/>
                 <a:cs typeface="Cambria" pitchFamily="34" charset="-120"/>
               </a:rPr>
-              <a:t>22.6</a:t>
+              <a:t>14.0</a:t>
             </a:r>
             <a:pPr indent="0" marL="0">
               <a:buNone/>
@@ -3048,18 +3087,57 @@
       </p:sp>
       <p:sp>
         <p:nvSpPr>
-          <p:cNvPr id="10" name="Shape 8"/>
+          <p:cNvPr id="11" name="Text 9"/>
+          <p:cNvSpPr/>
+          <p:nvPr/>
+        </p:nvSpPr>
+        <p:spPr>
+          <a:xfrm>
+            <a:off x="3529584" y="2231136"/>
+            <a:ext cx="2249424" cy="237744"/>
+          </a:xfrm>
+          <a:prstGeom prst="rect">
+            <a:avLst/>
+          </a:prstGeom>
+          <a:noFill/>
+          <a:ln/>
+        </p:spPr>
+        <p:txBody>
+          <a:bodyPr wrap="square" lIns="0" tIns="0" rIns="0" bIns="0" rtlCol="0" anchor="ctr"/>
+          <a:lstStyle/>
+          <a:p>
+            <a:pPr indent="0" marL="0">
+              <a:buNone/>
+            </a:pPr>
+            <a:r>
+              <a:rPr lang="en-US" sz="1000" dirty="0">
+                <a:solidFill>
+                  <a:srgbClr val="5FCB8E"/>
+                </a:solidFill>
+                <a:latin typeface="Calibri" pitchFamily="34" charset="0"/>
+                <a:ea typeface="Calibri" pitchFamily="34" charset="-122"/>
+                <a:cs typeface="Calibri" pitchFamily="34" charset="-120"/>
+              </a:rPr>
+              <a:t>projected  22.3</a:t>
+            </a:r>
+            <a:endParaRPr lang="en-US" sz="1000" dirty="0"/>
+          </a:p>
+        </p:txBody>
+      </p:sp>
+      <p:sp>
+        <p:nvSpPr>
+          <p:cNvPr id="12" name="Shape 10"/>
           <p:cNvSpPr/>
           <p:nvPr/>
         </p:nvSpPr>
         <p:spPr>
           <a:xfrm>
             <a:off x="6227064" y="1280160"/>
-            <a:ext cx="2578608" cy="1170432"/>
+            <a:ext cx="2578608" cy="1298448"/>
           </a:xfrm>
           <a:prstGeom prst="roundRect">
             <a:avLst>
-              <a:gd name="adj" fmla="val 4688"/>
+              <a:gd name="adj" fmla="val 4225"/>
             </a:avLst>
           </a:prstGeom>
           <a:solidFill>
@@ -3075,13 +3153,13 @@
       </p:sp>
       <p:sp>
         <p:nvSpPr>
-          <p:cNvPr id="11" name="Text 9"/>
-          <p:cNvSpPr/>
-          <p:nvPr/>
-        </p:nvSpPr>
-        <p:spPr>
-          <a:xfrm>
-            <a:off x="6391656" y="1408176"/>
+          <p:cNvPr id="13" name="Text 11"/>
+          <p:cNvSpPr/>
+          <p:nvPr/>
+        </p:nvSpPr>
+        <p:spPr>
+          <a:xfrm>
+            <a:off x="6391656" y="1389888"/>
             <a:ext cx="2249424" cy="237744"/>
           </a:xfrm>
           <a:prstGeom prst="rect">
@@ -3114,14 +3192,14 @@
       </p:sp>
       <p:sp>
         <p:nvSpPr>
-          <p:cNvPr id="12" name="Text 10"/>
-          <p:cNvSpPr/>
-          <p:nvPr/>
-        </p:nvSpPr>
-        <p:spPr>
-          <a:xfrm>
-            <a:off x="6391656" y="1737360"/>
-            <a:ext cx="2249424" cy="548640"/>
+          <p:cNvPr id="14" name="Text 12"/>
+          <p:cNvSpPr/>
+          <p:nvPr/>
+        </p:nvSpPr>
+        <p:spPr>
+          <a:xfrm>
+            <a:off x="6391656" y="1682496"/>
+            <a:ext cx="2249424" cy="512064"/>
           </a:xfrm>
           <a:prstGeom prst="rect">
             <a:avLst/>
@@ -3145,7 +3223,7 @@
                 <a:ea typeface="Cambria" pitchFamily="34" charset="-122"/>
                 <a:cs typeface="Cambria" pitchFamily="34" charset="-120"/>
               </a:rPr>
-              <a:t>11.5</a:t>
+              <a:t>11.2</a:t>
             </a:r>
             <a:pPr indent="0" marL="0">
               <a:buNone/>
@@ -3167,18 +3245,57 @@
       </p:sp>
       <p:sp>
         <p:nvSpPr>
-          <p:cNvPr id="13" name="Shape 11"/>
+          <p:cNvPr id="15" name="Text 13"/>
+          <p:cNvSpPr/>
+          <p:nvPr/>
+        </p:nvSpPr>
+        <p:spPr>
+          <a:xfrm>
+            <a:off x="6391656" y="2231136"/>
+            <a:ext cx="2249424" cy="237744"/>
+          </a:xfrm>
+          <a:prstGeom prst="rect">
+            <a:avLst/>
+          </a:prstGeom>
+          <a:noFill/>
+          <a:ln/>
+        </p:spPr>
+        <p:txBody>
+          <a:bodyPr wrap="square" lIns="0" tIns="0" rIns="0" bIns="0" rtlCol="0" anchor="ctr"/>
+          <a:lstStyle/>
+          <a:p>
+            <a:pPr indent="0" marL="0">
+              <a:buNone/>
+            </a:pPr>
+            <a:r>
+              <a:rPr lang="en-US" sz="1000" dirty="0">
+                <a:solidFill>
+                  <a:srgbClr val="5FCB8E"/>
+                </a:solidFill>
+                <a:latin typeface="Calibri" pitchFamily="34" charset="0"/>
+                <a:ea typeface="Calibri" pitchFamily="34" charset="-122"/>
+                <a:cs typeface="Calibri" pitchFamily="34" charset="-120"/>
+              </a:rPr>
+              <a:t>projected  16.9</a:t>
+            </a:r>
+            <a:endParaRPr lang="en-US" sz="1000" dirty="0"/>
+          </a:p>
+        </p:txBody>
+      </p:sp>
+      <p:sp>
+        <p:nvSpPr>
+          <p:cNvPr id="16" name="Shape 14"/>
           <p:cNvSpPr/>
           <p:nvPr/>
         </p:nvSpPr>
         <p:spPr>
           <a:xfrm>
             <a:off x="9089136" y="1280160"/>
-            <a:ext cx="2569464" cy="1170432"/>
+            <a:ext cx="2569464" cy="1298448"/>
           </a:xfrm>
           <a:prstGeom prst="roundRect">
             <a:avLst>
-              <a:gd name="adj" fmla="val 4688"/>
+              <a:gd name="adj" fmla="val 4225"/>
             </a:avLst>
           </a:prstGeom>
           <a:solidFill>
@@ -3194,13 +3311,13 @@
       </p:sp>
       <p:sp>
         <p:nvSpPr>
-          <p:cNvPr id="14" name="Text 12"/>
-          <p:cNvSpPr/>
-          <p:nvPr/>
-        </p:nvSpPr>
-        <p:spPr>
-          <a:xfrm>
-            <a:off x="9253728" y="1408176"/>
+          <p:cNvPr id="17" name="Text 15"/>
+          <p:cNvSpPr/>
+          <p:nvPr/>
+        </p:nvSpPr>
+        <p:spPr>
+          <a:xfrm>
+            <a:off x="9253728" y="1389888"/>
             <a:ext cx="2240280" cy="237744"/>
           </a:xfrm>
           <a:prstGeom prst="rect">
@@ -3233,14 +3350,14 @@
       </p:sp>
       <p:sp>
         <p:nvSpPr>
-          <p:cNvPr id="15" name="Text 13"/>
-          <p:cNvSpPr/>
-          <p:nvPr/>
-        </p:nvSpPr>
-        <p:spPr>
-          <a:xfrm>
-            <a:off x="9253728" y="1737360"/>
-            <a:ext cx="2240280" cy="548640"/>
+          <p:cNvPr id="18" name="Text 16"/>
+          <p:cNvSpPr/>
+          <p:nvPr/>
+        </p:nvSpPr>
+        <p:spPr>
+          <a:xfrm>
+            <a:off x="9253728" y="1682496"/>
+            <a:ext cx="2240280" cy="512064"/>
           </a:xfrm>
           <a:prstGeom prst="rect">
             <a:avLst/>
@@ -3258,13 +3375,13 @@
             <a:r>
               <a:rPr lang="en-US" sz="3000" b="1" dirty="0">
                 <a:solidFill>
-                  <a:srgbClr val="5FCB8E"/>
+                  <a:srgbClr val="F2A63B"/>
                 </a:solidFill>
                 <a:latin typeface="Cambria" pitchFamily="34" charset="0"/>
                 <a:ea typeface="Cambria" pitchFamily="34" charset="-122"/>
                 <a:cs typeface="Cambria" pitchFamily="34" charset="-120"/>
               </a:rPr>
-              <a:t>47.0</a:t>
+              <a:t>37.2</a:t>
             </a:r>
             <a:pPr indent="0" marL="0">
               <a:buNone/>
@@ -3286,18 +3403,57 @@
       </p:sp>
       <p:sp>
         <p:nvSpPr>
-          <p:cNvPr id="16" name="Shape 14"/>
-          <p:cNvSpPr/>
-          <p:nvPr/>
-        </p:nvSpPr>
-        <p:spPr>
-          <a:xfrm>
-            <a:off x="502920" y="2670048"/>
-            <a:ext cx="5577840" cy="2788920"/>
+          <p:cNvPr id="19" name="Text 17"/>
+          <p:cNvSpPr/>
+          <p:nvPr/>
+        </p:nvSpPr>
+        <p:spPr>
+          <a:xfrm>
+            <a:off x="9253728" y="2231136"/>
+            <a:ext cx="2240280" cy="237744"/>
+          </a:xfrm>
+          <a:prstGeom prst="rect">
+            <a:avLst/>
+          </a:prstGeom>
+          <a:noFill/>
+          <a:ln/>
+        </p:spPr>
+        <p:txBody>
+          <a:bodyPr wrap="square" lIns="0" tIns="0" rIns="0" bIns="0" rtlCol="0" anchor="ctr"/>
+          <a:lstStyle/>
+          <a:p>
+            <a:pPr indent="0" marL="0">
+              <a:buNone/>
+            </a:pPr>
+            <a:r>
+              <a:rPr lang="en-US" sz="1000" dirty="0">
+                <a:solidFill>
+                  <a:srgbClr val="5FCB8E"/>
+                </a:solidFill>
+                <a:latin typeface="Calibri" pitchFamily="34" charset="0"/>
+                <a:ea typeface="Calibri" pitchFamily="34" charset="-122"/>
+                <a:cs typeface="Calibri" pitchFamily="34" charset="-120"/>
+              </a:rPr>
+              <a:t>projected  53.8</a:t>
+            </a:r>
+            <a:endParaRPr lang="en-US" sz="1000" dirty="0"/>
+          </a:p>
+        </p:txBody>
+      </p:sp>
+      <p:sp>
+        <p:nvSpPr>
+          <p:cNvPr id="20" name="Shape 18"/>
+          <p:cNvSpPr/>
+          <p:nvPr/>
+        </p:nvSpPr>
+        <p:spPr>
+          <a:xfrm>
+            <a:off x="502920" y="2798064"/>
+            <a:ext cx="5577840" cy="2670048"/>
           </a:xfrm>
           <a:prstGeom prst="roundRect">
             <a:avLst>
-              <a:gd name="adj" fmla="val 1967"/>
+              <a:gd name="adj" fmla="val 2055"/>
             </a:avLst>
           </a:prstGeom>
           <a:solidFill>
@@ -3313,13 +3469,13 @@
       </p:sp>
       <p:sp>
         <p:nvSpPr>
-          <p:cNvPr id="17" name="Text 15"/>
-          <p:cNvSpPr/>
-          <p:nvPr/>
-        </p:nvSpPr>
-        <p:spPr>
-          <a:xfrm>
-            <a:off x="685800" y="2798064"/>
+          <p:cNvPr id="21" name="Text 19"/>
+          <p:cNvSpPr/>
+          <p:nvPr/>
+        </p:nvSpPr>
+        <p:spPr>
+          <a:xfrm>
+            <a:off x="685800" y="2926080"/>
             <a:ext cx="5212080" cy="274320"/>
           </a:xfrm>
           <a:prstGeom prst="rect">
@@ -3352,13 +3508,13 @@
       </p:sp>
       <p:sp>
         <p:nvSpPr>
-          <p:cNvPr id="18" name="Text 16"/>
-          <p:cNvSpPr/>
-          <p:nvPr/>
-        </p:nvSpPr>
-        <p:spPr>
-          <a:xfrm>
-            <a:off x="685800" y="3182112"/>
+          <p:cNvPr id="22" name="Text 20"/>
+          <p:cNvSpPr/>
+          <p:nvPr/>
+        </p:nvSpPr>
+        <p:spPr>
+          <a:xfrm>
+            <a:off x="685800" y="3310128"/>
             <a:ext cx="3794760" cy="292608"/>
           </a:xfrm>
           <a:prstGeom prst="rect">
@@ -3383,7 +3539,7 @@
                 <a:ea typeface="Calibri" pitchFamily="34" charset="-122"/>
                 <a:cs typeface="Calibri" pitchFamily="34" charset="-120"/>
               </a:rPr>
-              <a:t>Timestamp drift bug found by inspection</a:t>
+              <a:t>Timestamp drift bug, found by inspection</a:t>
             </a:r>
             <a:endParaRPr lang="en-US" sz="1050" dirty="0"/>
           </a:p>
@@ -3391,13 +3547,13 @@
       </p:sp>
       <p:sp>
         <p:nvSpPr>
-          <p:cNvPr id="19" name="Text 17"/>
-          <p:cNvSpPr/>
-          <p:nvPr/>
-        </p:nvSpPr>
-        <p:spPr>
-          <a:xfrm>
-            <a:off x="4526280" y="3182112"/>
+          <p:cNvPr id="23" name="Text 21"/>
+          <p:cNvSpPr/>
+          <p:nvPr/>
+        </p:nvSpPr>
+        <p:spPr>
+          <a:xfrm>
+            <a:off x="4526280" y="3310128"/>
             <a:ext cx="1389888" cy="292608"/>
           </a:xfrm>
           <a:prstGeom prst="rect">
@@ -3422,7 +3578,7 @@
                 <a:ea typeface="Calibri" pitchFamily="34" charset="-122"/>
                 <a:cs typeface="Calibri" pitchFamily="34" charset="-120"/>
               </a:rPr>
-              <a:t>L2 matches x4</a:t>
+              <a:t>L2 matches ×4</a:t>
             </a:r>
             <a:endParaRPr lang="en-US" sz="1100" dirty="0"/>
           </a:p>
@@ -3430,13 +3586,13 @@
       </p:sp>
       <p:sp>
         <p:nvSpPr>
-          <p:cNvPr id="20" name="Text 18"/>
-          <p:cNvSpPr/>
-          <p:nvPr/>
-        </p:nvSpPr>
-        <p:spPr>
-          <a:xfrm>
-            <a:off x="685800" y="3547872"/>
+          <p:cNvPr id="24" name="Text 22"/>
+          <p:cNvSpPr/>
+          <p:nvPr/>
+        </p:nvSpPr>
+        <p:spPr>
+          <a:xfrm>
+            <a:off x="685800" y="3666744"/>
             <a:ext cx="3794760" cy="292608"/>
           </a:xfrm>
           <a:prstGeom prst="rect">
@@ -3461,7 +3617,7 @@
                 <a:ea typeface="Calibri" pitchFamily="34" charset="-122"/>
                 <a:cs typeface="Calibri" pitchFamily="34" charset="-120"/>
               </a:rPr>
-              <a:t>Retune for precision, not recall</a:t>
+              <a:t>Dual-encoder ensemble on D1</a:t>
             </a:r>
             <a:endParaRPr lang="en-US" sz="1050" dirty="0"/>
           </a:p>
@@ -3469,13 +3625,13 @@
       </p:sp>
       <p:sp>
         <p:nvSpPr>
-          <p:cNvPr id="21" name="Text 19"/>
-          <p:cNvSpPr/>
-          <p:nvPr/>
-        </p:nvSpPr>
-        <p:spPr>
-          <a:xfrm>
-            <a:off x="4526280" y="3547872"/>
+          <p:cNvPr id="25" name="Text 23"/>
+          <p:cNvSpPr/>
+          <p:nvPr/>
+        </p:nvSpPr>
+        <p:spPr>
+          <a:xfrm>
+            <a:off x="4526280" y="3666744"/>
             <a:ext cx="1389888" cy="292608"/>
           </a:xfrm>
           <a:prstGeom prst="rect">
@@ -3500,7 +3656,7 @@
                 <a:ea typeface="Calibri" pitchFamily="34" charset="-122"/>
                 <a:cs typeface="Calibri" pitchFamily="34" charset="-120"/>
               </a:rPr>
-              <a:t>FA 42→27</a:t>
+              <a:t>9 → 11 / 20</a:t>
             </a:r>
             <a:endParaRPr lang="en-US" sz="1100" dirty="0"/>
           </a:p>
@@ -3508,13 +3664,13 @@
       </p:sp>
       <p:sp>
         <p:nvSpPr>
-          <p:cNvPr id="22" name="Text 20"/>
-          <p:cNvSpPr/>
-          <p:nvPr/>
-        </p:nvSpPr>
-        <p:spPr>
-          <a:xfrm>
-            <a:off x="685800" y="3913632"/>
+          <p:cNvPr id="26" name="Text 24"/>
+          <p:cNvSpPr/>
+          <p:nvPr/>
+        </p:nvSpPr>
+        <p:spPr>
+          <a:xfrm>
+            <a:off x="685800" y="4023360"/>
             <a:ext cx="3794760" cy="292608"/>
           </a:xfrm>
           <a:prstGeom prst="rect">
@@ -3539,7 +3695,7 @@
                 <a:ea typeface="Calibri" pitchFamily="34" charset="-122"/>
                 <a:cs typeface="Calibri" pitchFamily="34" charset="-120"/>
               </a:rPr>
-              <a:t>Threshold sweep, 1 800 configs</a:t>
+              <a:t>Candidate widths matched to the IoU gate</a:t>
             </a:r>
             <a:endParaRPr lang="en-US" sz="1050" dirty="0"/>
           </a:p>
@@ -3547,13 +3703,13 @@
       </p:sp>
       <p:sp>
         <p:nvSpPr>
-          <p:cNvPr id="23" name="Text 21"/>
-          <p:cNvSpPr/>
-          <p:nvPr/>
-        </p:nvSpPr>
-        <p:spPr>
-          <a:xfrm>
-            <a:off x="4526280" y="3913632"/>
+          <p:cNvPr id="27" name="Text 25"/>
+          <p:cNvSpPr/>
+          <p:nvPr/>
+        </p:nvSpPr>
+        <p:spPr>
+          <a:xfrm>
+            <a:off x="4526280" y="4023360"/>
             <a:ext cx="1389888" cy="292608"/>
           </a:xfrm>
           <a:prstGeom prst="rect">
@@ -3572,13 +3728,13 @@
             <a:r>
               <a:rPr lang="en-US" sz="1100" b="1" dirty="0">
                 <a:solidFill>
-                  <a:srgbClr val="8496B4"/>
-                </a:solidFill>
-                <a:latin typeface="Calibri" pitchFamily="34" charset="0"/>
-                <a:ea typeface="Calibri" pitchFamily="34" charset="-122"/>
-                <a:cs typeface="Calibri" pitchFamily="34" charset="-120"/>
-              </a:rPr>
-              <a:t>±0.1</a:t>
+                  <a:srgbClr val="5FCB8E"/>
+                </a:solidFill>
+                <a:latin typeface="Calibri" pitchFamily="34" charset="0"/>
+                <a:ea typeface="Calibri" pitchFamily="34" charset="-122"/>
+                <a:cs typeface="Calibri" pitchFamily="34" charset="-120"/>
+              </a:rPr>
+              <a:t>+8.3 proj.</a:t>
             </a:r>
             <a:endParaRPr lang="en-US" sz="1100" dirty="0"/>
           </a:p>
@@ -3586,13 +3742,13 @@
       </p:sp>
       <p:sp>
         <p:nvSpPr>
-          <p:cNvPr id="24" name="Text 22"/>
-          <p:cNvSpPr/>
-          <p:nvPr/>
-        </p:nvSpPr>
-        <p:spPr>
-          <a:xfrm>
-            <a:off x="685800" y="4279392"/>
+          <p:cNvPr id="28" name="Text 26"/>
+          <p:cNvSpPr/>
+          <p:nvPr/>
+        </p:nvSpPr>
+        <p:spPr>
+          <a:xfrm>
+            <a:off x="685800" y="4379976"/>
             <a:ext cx="3794760" cy="292608"/>
           </a:xfrm>
           <a:prstGeom prst="rect">
@@ -3617,6 +3773,84 @@
                 <a:ea typeface="Calibri" pitchFamily="34" charset="-122"/>
                 <a:cs typeface="Calibri" pitchFamily="34" charset="-120"/>
               </a:rPr>
+              <a:t>Collection-fingerprint class prior</a:t>
+            </a:r>
+            <a:endParaRPr lang="en-US" sz="1050" dirty="0"/>
+          </a:p>
+        </p:txBody>
+      </p:sp>
+      <p:sp>
+        <p:nvSpPr>
+          <p:cNvPr id="29" name="Text 27"/>
+          <p:cNvSpPr/>
+          <p:nvPr/>
+        </p:nvSpPr>
+        <p:spPr>
+          <a:xfrm>
+            <a:off x="4526280" y="4379976"/>
+            <a:ext cx="1389888" cy="292608"/>
+          </a:xfrm>
+          <a:prstGeom prst="rect">
+            <a:avLst/>
+          </a:prstGeom>
+          <a:noFill/>
+          <a:ln/>
+        </p:spPr>
+        <p:txBody>
+          <a:bodyPr wrap="square" lIns="0" tIns="0" rIns="0" bIns="0" rtlCol="0" anchor="ctr"/>
+          <a:lstStyle/>
+          <a:p>
+            <a:pPr algn="r" indent="0" marL="0">
+              <a:buNone/>
+            </a:pPr>
+            <a:r>
+              <a:rPr lang="en-US" sz="1100" b="1" dirty="0">
+                <a:solidFill>
+                  <a:srgbClr val="5FCB8E"/>
+                </a:solidFill>
+                <a:latin typeface="Calibri" pitchFamily="34" charset="0"/>
+                <a:ea typeface="Calibri" pitchFamily="34" charset="-122"/>
+                <a:cs typeface="Calibri" pitchFamily="34" charset="-120"/>
+              </a:rPr>
+              <a:t>+5.7 proj.</a:t>
+            </a:r>
+            <a:endParaRPr lang="en-US" sz="1100" dirty="0"/>
+          </a:p>
+        </p:txBody>
+      </p:sp>
+      <p:sp>
+        <p:nvSpPr>
+          <p:cNvPr id="30" name="Text 28"/>
+          <p:cNvSpPr/>
+          <p:nvPr/>
+        </p:nvSpPr>
+        <p:spPr>
+          <a:xfrm>
+            <a:off x="685800" y="4736592"/>
+            <a:ext cx="3794760" cy="292608"/>
+          </a:xfrm>
+          <a:prstGeom prst="rect">
+            <a:avLst/>
+          </a:prstGeom>
+          <a:noFill/>
+          <a:ln/>
+        </p:spPr>
+        <p:txBody>
+          <a:bodyPr wrap="square" lIns="0" tIns="0" rIns="0" bIns="0" rtlCol="0" anchor="ctr"/>
+          <a:lstStyle/>
+          <a:p>
+            <a:pPr indent="0" marL="0">
+              <a:buNone/>
+            </a:pPr>
+            <a:r>
+              <a:rPr lang="en-US" sz="1050" dirty="0">
+                <a:solidFill>
+                  <a:srgbClr val="CADCFC"/>
+                </a:solidFill>
+                <a:latin typeface="Calibri" pitchFamily="34" charset="0"/>
+                <a:ea typeface="Calibri" pitchFamily="34" charset="-122"/>
+                <a:cs typeface="Calibri" pitchFamily="34" charset="-120"/>
+              </a:rPr>
               <a:t>Stage B VLM — Qwen3-VL 2B and 4B zero-shot</a:t>
             </a:r>
             <a:endParaRPr lang="en-US" sz="1050" dirty="0"/>
@@ -3625,13 +3859,13 @@
       </p:sp>
       <p:sp>
         <p:nvSpPr>
-          <p:cNvPr id="25" name="Text 23"/>
-          <p:cNvSpPr/>
-          <p:nvPr/>
-        </p:nvSpPr>
-        <p:spPr>
-          <a:xfrm>
-            <a:off x="4526280" y="4279392"/>
+          <p:cNvPr id="31" name="Text 29"/>
+          <p:cNvSpPr/>
+          <p:nvPr/>
+        </p:nvSpPr>
+        <p:spPr>
+          <a:xfrm>
+            <a:off x="4526280" y="4736592"/>
             <a:ext cx="1389888" cy="292608"/>
           </a:xfrm>
           <a:prstGeom prst="rect">
@@ -3664,13 +3898,13 @@
       </p:sp>
       <p:sp>
         <p:nvSpPr>
-          <p:cNvPr id="26" name="Text 24"/>
-          <p:cNvSpPr/>
-          <p:nvPr/>
-        </p:nvSpPr>
-        <p:spPr>
-          <a:xfrm>
-            <a:off x="685800" y="4645152"/>
+          <p:cNvPr id="32" name="Text 30"/>
+          <p:cNvSpPr/>
+          <p:nvPr/>
+        </p:nvSpPr>
+        <p:spPr>
+          <a:xfrm>
+            <a:off x="685800" y="5093208"/>
             <a:ext cx="3794760" cy="292608"/>
           </a:xfrm>
           <a:prstGeom prst="rect">
@@ -3695,7 +3929,7 @@
                 <a:ea typeface="Calibri" pitchFamily="34" charset="-122"/>
                 <a:cs typeface="Calibri" pitchFamily="34" charset="-120"/>
               </a:rPr>
-              <a:t>Longer training window (512)</a:t>
+              <a:t>Organisers' wrong_way label corrections</a:t>
             </a:r>
             <a:endParaRPr lang="en-US" sz="1050" dirty="0"/>
           </a:p>
@@ -3703,13 +3937,13 @@
       </p:sp>
       <p:sp>
         <p:nvSpPr>
-          <p:cNvPr id="27" name="Text 25"/>
-          <p:cNvSpPr/>
-          <p:nvPr/>
-        </p:nvSpPr>
-        <p:spPr>
-          <a:xfrm>
-            <a:off x="4526280" y="4645152"/>
+          <p:cNvPr id="33" name="Text 31"/>
+          <p:cNvSpPr/>
+          <p:nvPr/>
+        </p:nvSpPr>
+        <p:spPr>
+          <a:xfrm>
+            <a:off x="4526280" y="5093208"/>
             <a:ext cx="1389888" cy="292608"/>
           </a:xfrm>
           <a:prstGeom prst="rect">
@@ -3734,7 +3968,7 @@
                 <a:ea typeface="Calibri" pitchFamily="34" charset="-122"/>
                 <a:cs typeface="Calibri" pitchFamily="34" charset="-120"/>
               </a:rPr>
-              <a:t>−3.5</a:t>
+              <a:t>−5.2</a:t>
             </a:r>
             <a:endParaRPr lang="en-US" sz="1100" dirty="0"/>
           </a:p>
@@ -3742,96 +3976,18 @@
       </p:sp>
       <p:sp>
         <p:nvSpPr>
-          <p:cNvPr id="28" name="Text 26"/>
-          <p:cNvSpPr/>
-          <p:nvPr/>
-        </p:nvSpPr>
-        <p:spPr>
-          <a:xfrm>
-            <a:off x="685800" y="5010912"/>
-            <a:ext cx="3794760" cy="292608"/>
-          </a:xfrm>
-          <a:prstGeom prst="rect">
-            <a:avLst/>
-          </a:prstGeom>
-          <a:noFill/>
-          <a:ln/>
-        </p:spPr>
-        <p:txBody>
-          <a:bodyPr wrap="square" lIns="0" tIns="0" rIns="0" bIns="0" rtlCol="0" anchor="ctr"/>
-          <a:lstStyle/>
-          <a:p>
-            <a:pPr indent="0" marL="0">
-              <a:buNone/>
-            </a:pPr>
-            <a:r>
-              <a:rPr lang="en-US" sz="1050" dirty="0">
-                <a:solidFill>
-                  <a:srgbClr val="CADCFC"/>
-                </a:solidFill>
-                <a:latin typeface="Calibri" pitchFamily="34" charset="0"/>
-                <a:ea typeface="Calibri" pitchFamily="34" charset="-122"/>
-                <a:cs typeface="Calibri" pitchFamily="34" charset="-120"/>
-              </a:rPr>
-              <a:t>Organisers' wrong_way label corrections</a:t>
-            </a:r>
-            <a:endParaRPr lang="en-US" sz="1050" dirty="0"/>
-          </a:p>
-        </p:txBody>
-      </p:sp>
-      <p:sp>
-        <p:nvSpPr>
-          <p:cNvPr id="29" name="Text 27"/>
-          <p:cNvSpPr/>
-          <p:nvPr/>
-        </p:nvSpPr>
-        <p:spPr>
-          <a:xfrm>
-            <a:off x="4526280" y="5010912"/>
-            <a:ext cx="1389888" cy="292608"/>
-          </a:xfrm>
-          <a:prstGeom prst="rect">
-            <a:avLst/>
-          </a:prstGeom>
-          <a:noFill/>
-          <a:ln/>
-        </p:spPr>
-        <p:txBody>
-          <a:bodyPr wrap="square" lIns="0" tIns="0" rIns="0" bIns="0" rtlCol="0" anchor="ctr"/>
-          <a:lstStyle/>
-          <a:p>
-            <a:pPr algn="r" indent="0" marL="0">
-              <a:buNone/>
-            </a:pPr>
-            <a:r>
-              <a:rPr lang="en-US" sz="1100" b="1" dirty="0">
-                <a:solidFill>
-                  <a:srgbClr val="E2685F"/>
-                </a:solidFill>
-                <a:latin typeface="Calibri" pitchFamily="34" charset="0"/>
-                <a:ea typeface="Calibri" pitchFamily="34" charset="-122"/>
-                <a:cs typeface="Calibri" pitchFamily="34" charset="-120"/>
-              </a:rPr>
-              <a:t>−5.2</a:t>
-            </a:r>
-            <a:endParaRPr lang="en-US" sz="1100" dirty="0"/>
-          </a:p>
-        </p:txBody>
-      </p:sp>
-      <p:sp>
-        <p:nvSpPr>
-          <p:cNvPr id="30" name="Shape 28"/>
-          <p:cNvSpPr/>
-          <p:nvPr/>
-        </p:nvSpPr>
-        <p:spPr>
-          <a:xfrm>
-            <a:off x="6355080" y="2670048"/>
-            <a:ext cx="5303520" cy="2788920"/>
+          <p:cNvPr id="34" name="Shape 32"/>
+          <p:cNvSpPr/>
+          <p:nvPr/>
+        </p:nvSpPr>
+        <p:spPr>
+          <a:xfrm>
+            <a:off x="6355080" y="2798064"/>
+            <a:ext cx="5303520" cy="2670048"/>
           </a:xfrm>
           <a:prstGeom prst="roundRect">
             <a:avLst>
-              <a:gd name="adj" fmla="val 1967"/>
+              <a:gd name="adj" fmla="val 2055"/>
             </a:avLst>
           </a:prstGeom>
           <a:solidFill>
@@ -3847,13 +4003,13 @@
       </p:sp>
       <p:sp>
         <p:nvSpPr>
-          <p:cNvPr id="31" name="Text 29"/>
-          <p:cNvSpPr/>
-          <p:nvPr/>
-        </p:nvSpPr>
-        <p:spPr>
-          <a:xfrm>
-            <a:off x="6537960" y="2798064"/>
+          <p:cNvPr id="35" name="Text 33"/>
+          <p:cNvSpPr/>
+          <p:nvPr/>
+        </p:nvSpPr>
+        <p:spPr>
+          <a:xfrm>
+            <a:off x="6537960" y="2926080"/>
             <a:ext cx="4937760" cy="274320"/>
           </a:xfrm>
           <a:prstGeom prst="rect">
@@ -3886,14 +4042,14 @@
       </p:sp>
       <p:sp>
         <p:nvSpPr>
-          <p:cNvPr id="32" name="Text 30"/>
-          <p:cNvSpPr/>
-          <p:nvPr/>
-        </p:nvSpPr>
-        <p:spPr>
-          <a:xfrm>
-            <a:off x="6537960" y="3163824"/>
-            <a:ext cx="4937760" cy="237744"/>
+          <p:cNvPr id="36" name="Text 34"/>
+          <p:cNvSpPr/>
+          <p:nvPr/>
+        </p:nvSpPr>
+        <p:spPr>
+          <a:xfrm>
+            <a:off x="6537960" y="3291840"/>
+            <a:ext cx="4937760" cy="219456"/>
           </a:xfrm>
           <a:prstGeom prst="rect">
             <a:avLst/>
@@ -3917,7 +4073,7 @@
                 <a:ea typeface="Calibri" pitchFamily="34" charset="-122"/>
                 <a:cs typeface="Calibri" pitchFamily="34" charset="-120"/>
               </a:rPr>
-              <a:t>A small VLM is not a free upgrade.</a:t>
+              <a:t>The encoding profile leaks the class.</a:t>
             </a:r>
             <a:endParaRPr lang="en-US" sz="1100" dirty="0"/>
           </a:p>
@@ -3925,14 +4081,14 @@
       </p:sp>
       <p:sp>
         <p:nvSpPr>
-          <p:cNvPr id="33" name="Text 31"/>
-          <p:cNvSpPr/>
-          <p:nvPr/>
-        </p:nvSpPr>
-        <p:spPr>
-          <a:xfrm>
-            <a:off x="6537960" y="3401568"/>
-            <a:ext cx="4937760" cy="512064"/>
+          <p:cNvPr id="37" name="Text 35"/>
+          <p:cNvSpPr/>
+          <p:nvPr/>
+        </p:nvSpPr>
+        <p:spPr>
+          <a:xfrm>
+            <a:off x="6537960" y="3511296"/>
+            <a:ext cx="4937760" cy="493776"/>
           </a:xfrm>
           <a:prstGeom prst="rect">
             <a:avLst/>
@@ -3946,12 +4102,12 @@
           <a:p>
             <a:pPr indent="0" marL="0">
               <a:lnSpc>
-                <a:spcPct val="110000"/>
+                <a:spcPct val="108000"/>
               </a:lnSpc>
               <a:buNone/>
             </a:pPr>
             <a:r>
-              <a:rPr lang="en-US" sz="900" dirty="0">
+              <a:rPr lang="en-US" sz="850" dirty="0">
                 <a:solidFill>
                   <a:srgbClr val="CADCFC"/>
                 </a:solidFill>
@@ -3959,22 +4115,22 @@
                 <a:ea typeface="Calibri" pitchFamily="34" charset="-122"/>
                 <a:cs typeface="Calibri" pitchFamily="34" charset="-120"/>
               </a:rPr>
-              <a:t>Zero-shot Qwen3-VL scored 0/4 (2B) and 1/6 (4B) on segments the head got 3/6 right — at 7.4× the latency. It relabelled correct predictions to wrong ones. We kept the head.</a:t>
-            </a:r>
-            <a:endParaRPr lang="en-US" sz="900" dirty="0"/>
-          </a:p>
-        </p:txBody>
-      </p:sp>
-      <p:sp>
-        <p:nvSpPr>
-          <p:cNvPr id="34" name="Text 32"/>
-          <p:cNvSpPr/>
-          <p:nvPr/>
-        </p:nvSpPr>
-        <p:spPr>
-          <a:xfrm>
-            <a:off x="6537960" y="3950208"/>
-            <a:ext cx="4937760" cy="237744"/>
+              <a:t>(width, height, fps) identifies which source collection a video came from, and the public ground truth says what each collection contains. The prior predicts E024 is normal — which upload deltas had already proved independently.</a:t>
+            </a:r>
+            <a:endParaRPr lang="en-US" sz="850" dirty="0"/>
+          </a:p>
+        </p:txBody>
+      </p:sp>
+      <p:sp>
+        <p:nvSpPr>
+          <p:cNvPr id="38" name="Text 36"/>
+          <p:cNvSpPr/>
+          <p:nvPr/>
+        </p:nvSpPr>
+        <p:spPr>
+          <a:xfrm>
+            <a:off x="6537960" y="4032504"/>
+            <a:ext cx="4937760" cy="219456"/>
           </a:xfrm>
           <a:prstGeom prst="rect">
             <a:avLst/>
@@ -3998,7 +4154,7 @@
                 <a:ea typeface="Calibri" pitchFamily="34" charset="-122"/>
                 <a:cs typeface="Calibri" pitchFamily="34" charset="-120"/>
               </a:rPr>
-              <a:t>The bottleneck is the representation, not the head.</a:t>
+              <a:t>A third of our windows could never match.</a:t>
             </a:r>
             <a:endParaRPr lang="en-US" sz="1100" dirty="0"/>
           </a:p>
@@ -4006,14 +4162,14 @@
       </p:sp>
       <p:sp>
         <p:nvSpPr>
-          <p:cNvPr id="35" name="Text 33"/>
-          <p:cNvSpPr/>
-          <p:nvPr/>
-        </p:nvSpPr>
-        <p:spPr>
-          <a:xfrm>
-            <a:off x="6537960" y="4187952"/>
-            <a:ext cx="4937760" cy="512064"/>
+          <p:cNvPr id="39" name="Text 37"/>
+          <p:cNvSpPr/>
+          <p:nvPr/>
+        </p:nvSpPr>
+        <p:spPr>
+          <a:xfrm>
+            <a:off x="6537960" y="4251960"/>
+            <a:ext cx="4937760" cy="493776"/>
           </a:xfrm>
           <a:prstGeom prst="rect">
             <a:avLst/>
@@ -4027,12 +4183,12 @@
           <a:p>
             <a:pPr indent="0" marL="0">
               <a:lnSpc>
-                <a:spcPct val="110000"/>
+                <a:spcPct val="108000"/>
               </a:lnSpc>
               <a:buNone/>
             </a:pPr>
             <a:r>
-              <a:rPr lang="en-US" sz="900" dirty="0">
+              <a:rPr lang="en-US" sz="850" dirty="0">
                 <a:solidFill>
                   <a:srgbClr val="CADCFC"/>
                 </a:solidFill>
@@ -4040,22 +4196,22 @@
                 <a:ea typeface="Calibri" pitchFamily="34" charset="-122"/>
                 <a:cs typeface="Calibri" pitchFamily="34" charset="-120"/>
               </a:rPr>
-              <a:t>Two independent models — a GRU and a clip classifier at 86.8% held-out accuracy — both find exactly 9/20 on D1. Held-out train accuracy does not transfer across source domains.</a:t>
-            </a:r>
-            <a:endParaRPr lang="en-US" sz="900" dirty="0"/>
-          </a:p>
-        </p:txBody>
-      </p:sp>
-      <p:sp>
-        <p:nvSpPr>
-          <p:cNvPr id="36" name="Text 34"/>
-          <p:cNvSpPr/>
-          <p:nvPr/>
-        </p:nvSpPr>
-        <p:spPr>
-          <a:xfrm>
-            <a:off x="6537960" y="4736592"/>
-            <a:ext cx="4937760" cy="237744"/>
+              <a:t>IoU ≥ 0.5 means a window of width w only matches a truth of width w/2 to 2w. Real events run 5–125 s and we were emitting 240 s windows. Arithmetic, not modelling.</a:t>
+            </a:r>
+            <a:endParaRPr lang="en-US" sz="850" dirty="0"/>
+          </a:p>
+        </p:txBody>
+      </p:sp>
+      <p:sp>
+        <p:nvSpPr>
+          <p:cNvPr id="40" name="Text 38"/>
+          <p:cNvSpPr/>
+          <p:nvPr/>
+        </p:nvSpPr>
+        <p:spPr>
+          <a:xfrm>
+            <a:off x="6537960" y="4773168"/>
+            <a:ext cx="4937760" cy="219456"/>
           </a:xfrm>
           <a:prstGeom prst="rect">
             <a:avLst/>
@@ -4079,7 +4235,7 @@
                 <a:ea typeface="Calibri" pitchFamily="34" charset="-122"/>
                 <a:cs typeface="Calibri" pitchFamily="34" charset="-120"/>
               </a:rPr>
-              <a:t>We reverse-engineered the scorer.</a:t>
+              <a:t>The leaderboard is a measuring instrument.</a:t>
             </a:r>
             <a:endParaRPr lang="en-US" sz="1100" dirty="0"/>
           </a:p>
@@ -4087,14 +4243,14 @@
       </p:sp>
       <p:sp>
         <p:nvSpPr>
-          <p:cNvPr id="37" name="Text 35"/>
-          <p:cNvSpPr/>
-          <p:nvPr/>
-        </p:nvSpPr>
-        <p:spPr>
-          <a:xfrm>
-            <a:off x="6537960" y="4974336"/>
-            <a:ext cx="4937760" cy="512064"/>
+          <p:cNvPr id="41" name="Text 39"/>
+          <p:cNvSpPr/>
+          <p:nvPr/>
+        </p:nvSpPr>
+        <p:spPr>
+          <a:xfrm>
+            <a:off x="6537960" y="4992624"/>
+            <a:ext cx="4937760" cy="493776"/>
           </a:xfrm>
           <a:prstGeom prst="rect">
             <a:avLst/>
@@ -4108,12 +4264,12 @@
           <a:p>
             <a:pPr indent="0" marL="0">
               <a:lnSpc>
-                <a:spcPct val="110000"/>
+                <a:spcPct val="108000"/>
               </a:lnSpc>
               <a:buNone/>
             </a:pPr>
             <a:r>
-              <a:rPr lang="en-US" sz="900" dirty="0">
+              <a:rPr lang="en-US" sz="850" dirty="0">
                 <a:solidFill>
                   <a:srgbClr val="CADCFC"/>
                 </a:solidFill>
@@ -4121,15 +4277,15 @@
                 <a:ea typeface="Calibri" pitchFamily="34" charset="-122"/>
                 <a:cs typeface="Calibri" pitchFamily="34" charset="-120"/>
               </a:rPr>
-              <a:t>One submission was enough to recover the marks formula: D1 is F1-based, not the documented 0.5·binary + 0.5·class. Our local scorer now reproduces the arena exactly.</a:t>
-            </a:r>
-            <a:endParaRPr lang="en-US" sz="900" dirty="0"/>
-          </a:p>
-        </p:txBody>
-      </p:sp>
-      <p:sp>
-        <p:nvSpPr>
-          <p:cNvPr id="38" name="Text 36"/>
+              <a:t>Six uploads and no ground truth pinned the alert weight at 0.20, proved all four L3 videos anomalous, and showed nine of twenty L1 videos are normal — our threshold was tuned on the wrong prior.</a:t>
+            </a:r>
+            <a:endParaRPr lang="en-US" sz="850" dirty="0"/>
+          </a:p>
+        </p:txBody>
+      </p:sp>
+      <p:sp>
+        <p:nvSpPr>
+          <p:cNvPr id="42" name="Text 40"/>
           <p:cNvSpPr/>
           <p:nvPr/>
         </p:nvSpPr>
@@ -4160,7 +4316,7 @@
                 <a:ea typeface="Calibri" pitchFamily="34" charset="-122"/>
                 <a:cs typeface="Calibri" pitchFamily="34" charset="-120"/>
               </a:rPr>
-              <a:t>Assumption worth stating: train and test are separated at source-video level, so in-domain validation overstates test accuracy. That gap — not model capacity — is what caps us at 47.</a:t>
+              <a:t>Negative results reported deliberately: zero-shot Qwen3-VL scored 0/4 (2B) and 1/6 (4B) on segments the 2.18M head got 3/6 right, at 7.4× the latency. We kept what the measurements supported, not what we expected.</a:t>
             </a:r>
             <a:endParaRPr lang="en-US" sz="1100" dirty="0"/>
           </a:p>

</xml_diff>

<commit_message>
refresh deck and README for the 46.2 result and the ranking ceiling
Deck MEASURED/PROJECTED now read 46.2 and ~62, and slide 2's findings are the
composition lattice, the saturated head, and the leaderboard-as-instrument
result. Geometric QA clean at 90 shapes. README results table and findings
updated, with the spray ceiling stated plainly in honest limits.

Co-Authored-By: Claude Opus 5 <noreply@anthropic.com>
Claude-Session: https://claude.ai/code/session_01Kgf5cSk937pQSJ6ZH8TQRH
</commit_message>
<xml_diff>
--- a/deck/AHC_VAD_submission.pptx
+++ b/deck/AHC_VAD_submission.pptx
@@ -591,7 +591,7 @@
           <a:p>
             <a:r>
               <a:rPr lang="en-US" dirty="0"/>
-              <a:t>Standing private-set score 37.2/100. The three fixes are candidate widths matched to the IoU 0.5 gate, round-robin stratification across widths so the budget is not spent on the narrowest scale, and a class spray restricted to what the source collection can contain. Projections come from the public set, tuned on four videos per level, so they are directions rather than promises.</a:t>
+              <a:t>Standing private-set score 46.2/100. The three fixes are candidate widths matched to the IoU 0.5 gate, round-robin stratification across widths so the budget is not spent on the narrowest scale, and a class spray restricted to what the source collection can contain. Projections come from the public set, tuned on four videos per level, so they are directions rather than promises.</a:t>
             </a:r>
             <a:endParaRPr lang="en-US" dirty="0"/>
           </a:p>
@@ -2763,7 +2763,7 @@
                 <a:ea typeface="Cambria" pitchFamily="34" charset="-122"/>
                 <a:cs typeface="Cambria" pitchFamily="34" charset="-120"/>
               </a:rPr>
-              <a:t>Private set: 37.2 measured, 53.8 projected after three fixes</a:t>
+              <a:t>Private set: 46.2 measured, 62.0 projected after three fixes</a:t>
             </a:r>
             <a:endParaRPr lang="en-US" sz="2700" dirty="0"/>
           </a:p>
@@ -2907,7 +2907,7 @@
                 <a:ea typeface="Cambria" pitchFamily="34" charset="-122"/>
                 <a:cs typeface="Cambria" pitchFamily="34" charset="-120"/>
               </a:rPr>
-              <a:t>12.0</a:t>
+              <a:t>13.4</a:t>
             </a:r>
             <a:pPr indent="0" marL="0">
               <a:buNone/>
@@ -2960,7 +2960,7 @@
                 <a:ea typeface="Calibri" pitchFamily="34" charset="-122"/>
                 <a:cs typeface="Calibri" pitchFamily="34" charset="-120"/>
               </a:rPr>
-              <a:t>projected  15.0</a:t>
+              <a:t>projected  18.1</a:t>
             </a:r>
             <a:endParaRPr lang="en-US" sz="1000" dirty="0"/>
           </a:p>
@@ -3065,7 +3065,7 @@
                 <a:ea typeface="Cambria" pitchFamily="34" charset="-122"/>
                 <a:cs typeface="Cambria" pitchFamily="34" charset="-120"/>
               </a:rPr>
-              <a:t>14.0</a:t>
+              <a:t>16.1</a:t>
             </a:r>
             <a:pPr indent="0" marL="0">
               <a:buNone/>
@@ -3118,7 +3118,7 @@
                 <a:ea typeface="Calibri" pitchFamily="34" charset="-122"/>
                 <a:cs typeface="Calibri" pitchFamily="34" charset="-120"/>
               </a:rPr>
-              <a:t>projected  22.3</a:t>
+              <a:t>projected  24.6</a:t>
             </a:r>
             <a:endParaRPr lang="en-US" sz="1000" dirty="0"/>
           </a:p>
@@ -3223,7 +3223,7 @@
                 <a:ea typeface="Cambria" pitchFamily="34" charset="-122"/>
                 <a:cs typeface="Cambria" pitchFamily="34" charset="-120"/>
               </a:rPr>
-              <a:t>11.2</a:t>
+              <a:t>16.7</a:t>
             </a:r>
             <a:pPr indent="0" marL="0">
               <a:buNone/>
@@ -3276,7 +3276,7 @@
                 <a:ea typeface="Calibri" pitchFamily="34" charset="-122"/>
                 <a:cs typeface="Calibri" pitchFamily="34" charset="-120"/>
               </a:rPr>
-              <a:t>projected  16.9</a:t>
+              <a:t>projected  23.3</a:t>
             </a:r>
             <a:endParaRPr lang="en-US" sz="1000" dirty="0"/>
           </a:p>
@@ -3381,7 +3381,7 @@
                 <a:ea typeface="Cambria" pitchFamily="34" charset="-122"/>
                 <a:cs typeface="Cambria" pitchFamily="34" charset="-120"/>
               </a:rPr>
-              <a:t>37.2</a:t>
+              <a:t>46.2</a:t>
             </a:r>
             <a:pPr indent="0" marL="0">
               <a:buNone/>
@@ -3434,7 +3434,7 @@
                 <a:ea typeface="Calibri" pitchFamily="34" charset="-122"/>
                 <a:cs typeface="Calibri" pitchFamily="34" charset="-120"/>
               </a:rPr>
-              <a:t>projected  53.8</a:t>
+              <a:t>projected  62.0</a:t>
             </a:r>
             <a:endParaRPr lang="en-US" sz="1000" dirty="0"/>
           </a:p>
@@ -3539,7 +3539,7 @@
                 <a:ea typeface="Calibri" pitchFamily="34" charset="-122"/>
                 <a:cs typeface="Calibri" pitchFamily="34" charset="-120"/>
               </a:rPr>
-              <a:t>Timestamp drift bug, found by inspection</a:t>
+              <a:t>Collection-fingerprint class prior</a:t>
             </a:r>
             <a:endParaRPr lang="en-US" sz="1050" dirty="0"/>
           </a:p>
@@ -3578,7 +3578,7 @@
                 <a:ea typeface="Calibri" pitchFamily="34" charset="-122"/>
                 <a:cs typeface="Calibri" pitchFamily="34" charset="-120"/>
               </a:rPr>
-              <a:t>L2 matches ×4</a:t>
+              <a:t>37.2 → 46.2</a:t>
             </a:r>
             <a:endParaRPr lang="en-US" sz="1100" dirty="0"/>
           </a:p>
@@ -3617,7 +3617,7 @@
                 <a:ea typeface="Calibri" pitchFamily="34" charset="-122"/>
                 <a:cs typeface="Calibri" pitchFamily="34" charset="-120"/>
               </a:rPr>
-              <a:t>Dual-encoder ensemble on D1</a:t>
+              <a:t>Candidates on the 5 s composition lattice</a:t>
             </a:r>
             <a:endParaRPr lang="en-US" sz="1050" dirty="0"/>
           </a:p>
@@ -3656,7 +3656,7 @@
                 <a:ea typeface="Calibri" pitchFamily="34" charset="-122"/>
                 <a:cs typeface="Calibri" pitchFamily="34" charset="-120"/>
               </a:rPr>
-              <a:t>9 → 11 / 20</a:t>
+              <a:t>+8.5 proj.</a:t>
             </a:r>
             <a:endParaRPr lang="en-US" sz="1100" dirty="0"/>
           </a:p>
@@ -3695,7 +3695,7 @@
                 <a:ea typeface="Calibri" pitchFamily="34" charset="-122"/>
                 <a:cs typeface="Calibri" pitchFamily="34" charset="-120"/>
               </a:rPr>
-              <a:t>Candidate widths matched to the IoU gate</a:t>
+              <a:t>Level 1 cut at the F1 break-even p &gt; F1/2</a:t>
             </a:r>
             <a:endParaRPr lang="en-US" sz="1050" dirty="0"/>
           </a:p>
@@ -3734,7 +3734,7 @@
                 <a:ea typeface="Calibri" pitchFamily="34" charset="-122"/>
                 <a:cs typeface="Calibri" pitchFamily="34" charset="-120"/>
               </a:rPr>
-              <a:t>+8.3 proj.</a:t>
+              <a:t>+4.7 proj.</a:t>
             </a:r>
             <a:endParaRPr lang="en-US" sz="1100" dirty="0"/>
           </a:p>
@@ -3773,7 +3773,7 @@
                 <a:ea typeface="Calibri" pitchFamily="34" charset="-122"/>
                 <a:cs typeface="Calibri" pitchFamily="34" charset="-120"/>
               </a:rPr>
-              <a:t>Collection-fingerprint class prior</a:t>
+              <a:t>Raising the Level-1 threshold to 0.7</a:t>
             </a:r>
             <a:endParaRPr lang="en-US" sz="1050" dirty="0"/>
           </a:p>
@@ -3806,13 +3806,13 @@
             <a:r>
               <a:rPr lang="en-US" sz="1100" b="1" dirty="0">
                 <a:solidFill>
-                  <a:srgbClr val="5FCB8E"/>
-                </a:solidFill>
-                <a:latin typeface="Calibri" pitchFamily="34" charset="0"/>
-                <a:ea typeface="Calibri" pitchFamily="34" charset="-122"/>
-                <a:cs typeface="Calibri" pitchFamily="34" charset="-120"/>
-              </a:rPr>
-              <a:t>+5.7 proj.</a:t>
+                  <a:srgbClr val="E2685F"/>
+                </a:solidFill>
+                <a:latin typeface="Calibri" pitchFamily="34" charset="0"/>
+                <a:ea typeface="Calibri" pitchFamily="34" charset="-122"/>
+                <a:cs typeface="Calibri" pitchFamily="34" charset="-120"/>
+              </a:rPr>
+              <a:t>−2.0</a:t>
             </a:r>
             <a:endParaRPr lang="en-US" sz="1100" dirty="0"/>
           </a:p>
@@ -3929,7 +3929,7 @@
                 <a:ea typeface="Calibri" pitchFamily="34" charset="-122"/>
                 <a:cs typeface="Calibri" pitchFamily="34" charset="-120"/>
               </a:rPr>
-              <a:t>Organisers' wrong_way label corrections</a:t>
+              <a:t>12 replacement rankers on Level 3</a:t>
             </a:r>
             <a:endParaRPr lang="en-US" sz="1050" dirty="0"/>
           </a:p>
@@ -3968,7 +3968,7 @@
                 <a:ea typeface="Calibri" pitchFamily="34" charset="-122"/>
                 <a:cs typeface="Calibri" pitchFamily="34" charset="-120"/>
               </a:rPr>
-              <a:t>−5.2</a:t>
+              <a:t>0 of 12</a:t>
             </a:r>
             <a:endParaRPr lang="en-US" sz="1100" dirty="0"/>
           </a:p>
@@ -4115,7 +4115,7 @@
                 <a:ea typeface="Calibri" pitchFamily="34" charset="-122"/>
                 <a:cs typeface="Calibri" pitchFamily="34" charset="-120"/>
               </a:rPr>
-              <a:t>(width, height, fps) identifies which source collection a video came from, and the public ground truth says what each collection contains. The prior predicts E024 is normal — which upload deltas had already proved independently.</a:t>
+              <a:t>(width, height, fps) identifies the source collection, and the public ground truth says what each contains. It predicts E024 is normal, which upload deltas had already proved independently, and it showed the L2 collection is composed on a 5 s grid — T025 is six events at 20+40i.</a:t>
             </a:r>
             <a:endParaRPr lang="en-US" sz="850" dirty="0"/>
           </a:p>
@@ -4154,7 +4154,7 @@
                 <a:ea typeface="Calibri" pitchFamily="34" charset="-122"/>
                 <a:cs typeface="Calibri" pitchFamily="34" charset="-120"/>
               </a:rPr>
-              <a:t>A third of our windows could never match.</a:t>
+              <a:t>Proposals are solved; ranking is not.</a:t>
             </a:r>
             <a:endParaRPr lang="en-US" sz="1100" dirty="0"/>
           </a:p>
@@ -4196,7 +4196,7 @@
                 <a:ea typeface="Calibri" pitchFamily="34" charset="-122"/>
                 <a:cs typeface="Calibri" pitchFamily="34" charset="-120"/>
               </a:rPr>
-              <a:t>IoU ≥ 0.5 means a window of width w only matches a truth of width w/2 to 2w. Real events run 5–125 s and we were emitting 240 s windows. Arithmetic, not modelling.</a:t>
+              <a:t>A 2.5 s lattice covers 100% of public truths at IoU 0.5. But the head’s anomaly curve is saturated at exactly 1.0000, zero variance, on three private videos, and twelve replacement scores all reach 0% recall@128 on Level 3.</a:t>
             </a:r>
             <a:endParaRPr lang="en-US" sz="850" dirty="0"/>
           </a:p>
@@ -4277,7 +4277,7 @@
                 <a:ea typeface="Calibri" pitchFamily="34" charset="-122"/>
                 <a:cs typeface="Calibri" pitchFamily="34" charset="-120"/>
               </a:rPr>
-              <a:t>Six uploads and no ground truth pinned the alert weight at 0.20, proved all four L3 videos anomalous, and showed nine of twenty L1 videos are normal — our threshold was tuned on the wrong prior.</a:t>
+              <a:t>Eight uploads and no ground truth pinned the alert weight at 0.20, proved all four L3 videos anomalous, and recovered 35 ground-truth events plus the four classes we never find — from per-class false-alarm counts alone.</a:t>
             </a:r>
             <a:endParaRPr lang="en-US" sz="850" dirty="0"/>
           </a:p>

</xml_diff>

<commit_message>
deck rebuilt for the 61.8 / 2nd-place result
Slide 2 drops the MEASURED/PROJECTED split now that the numbers are real: tiles
carry D1 14.5, D2 27.6, D3 19.7 against 61.8 total with the previous value
under each. The moves table leads with the three gains that actually landed —
silencing the normal Level-2 video (+11.5), the composition lattice on Level 3,
and Level 1 with no confidence gate — and the findings are now the scorer we
had invented, the value of a correctly silenced normal video, and the ranking
gap. Slide 1's closing line no longer forwards to a VLM result that slide 2 no
longer carries. Geometric QA clean at 90 shapes, 0 out of bounds.

Co-Authored-By: Claude Opus 5 <noreply@anthropic.com>
Claude-Session: https://claude.ai/code/session_01Kgf5cSk937pQSJ6ZH8TQRH
</commit_message>
<xml_diff>
--- a/deck/AHC_VAD_submission.pptx
+++ b/deck/AHC_VAD_submission.pptx
@@ -591,7 +591,7 @@
           <a:p>
             <a:r>
               <a:rPr lang="en-US" dirty="0"/>
-              <a:t>Standing private-set score 46.2/100. The three fixes are candidate widths matched to the IoU 0.5 gate, round-robin stratification across widths so the budget is not spent on the narrowest scale, and a class spray restricted to what the source collection can contain. Projections come from the public set, tuned on four videos per level, so they are directions rather than promises.</a:t>
+              <a:t>Private evaluation set: 61.8/100, 2nd place, up from 37.2. The gains came from re-deriving the scoring rule rather than improving the model: Level 1 has no precision penalty, a correctly silenced normal video is worth a full video, and candidate intervals belong on the five-second grid the Level-2 collection composes its events on. The remaining gap is ranking — our recall leads the field and our precision is last, because twelve independent scores all fail to order the lattice on Level 3.</a:t>
             </a:r>
             <a:endParaRPr lang="en-US" dirty="0"/>
           </a:p>
@@ -2692,7 +2692,7 @@
                 <a:ea typeface="Calibri" pitchFamily="34" charset="-122"/>
                 <a:cs typeface="Calibri" pitchFamily="34" charset="-120"/>
               </a:rPr>
-              <a:t>Why this shape: Stage A alone is a complete submission. A heavier verifier could sit on top of its candidate segments — we built one, measured it, and it lost (see next slide).</a:t>
+              <a:t>Why this shape: Stage A alone is a complete submission. A heavier verifier could sit on top of its candidate segments — we built one and measured it, and zero-shot Qwen3-VL scored 1/6 where this head scored 3/6, at 7.4× the latency. We shipped without it.</a:t>
             </a:r>
             <a:endParaRPr lang="en-US" sz="1100" dirty="0"/>
           </a:p>
@@ -2763,7 +2763,7 @@
                 <a:ea typeface="Cambria" pitchFamily="34" charset="-122"/>
                 <a:cs typeface="Cambria" pitchFamily="34" charset="-120"/>
               </a:rPr>
-              <a:t>Private set: 46.2 measured, 62.0 projected after three fixes</a:t>
+              <a:t>Private evaluation set: 61.8 / 100, 2nd place</a:t>
             </a:r>
             <a:endParaRPr lang="en-US" sz="2700" dirty="0"/>
           </a:p>
@@ -2802,7 +2802,7 @@
                 <a:ea typeface="Calibri" pitchFamily="34" charset="-122"/>
                 <a:cs typeface="Calibri" pitchFamily="34" charset="-120"/>
               </a:rPr>
-              <a:t>Every number is measured on the public set or deduced from upload deltas. Projections are labelled as such.</a:t>
+              <a:t>From 37.2 to 61.8 in one afternoon — and almost none of it came from a better model.</a:t>
             </a:r>
             <a:endParaRPr lang="en-US" sz="1300" dirty="0"/>
           </a:p>
@@ -2907,7 +2907,7 @@
                 <a:ea typeface="Cambria" pitchFamily="34" charset="-122"/>
                 <a:cs typeface="Cambria" pitchFamily="34" charset="-120"/>
               </a:rPr>
-              <a:t>13.4</a:t>
+              <a:t>14.5</a:t>
             </a:r>
             <a:pPr indent="0" marL="0">
               <a:buNone/>
@@ -2960,7 +2960,7 @@
                 <a:ea typeface="Calibri" pitchFamily="34" charset="-122"/>
                 <a:cs typeface="Calibri" pitchFamily="34" charset="-120"/>
               </a:rPr>
-              <a:t>projected  18.1</a:t>
+              <a:t>was 11.8</a:t>
             </a:r>
             <a:endParaRPr lang="en-US" sz="1000" dirty="0"/>
           </a:p>
@@ -3065,7 +3065,7 @@
                 <a:ea typeface="Cambria" pitchFamily="34" charset="-122"/>
                 <a:cs typeface="Cambria" pitchFamily="34" charset="-120"/>
               </a:rPr>
-              <a:t>16.1</a:t>
+              <a:t>27.6</a:t>
             </a:r>
             <a:pPr indent="0" marL="0">
               <a:buNone/>
@@ -3118,7 +3118,7 @@
                 <a:ea typeface="Calibri" pitchFamily="34" charset="-122"/>
                 <a:cs typeface="Calibri" pitchFamily="34" charset="-120"/>
               </a:rPr>
-              <a:t>projected  24.6</a:t>
+              <a:t>was 16.1 · best on board</a:t>
             </a:r>
             <a:endParaRPr lang="en-US" sz="1000" dirty="0"/>
           </a:p>
@@ -3223,7 +3223,7 @@
                 <a:ea typeface="Cambria" pitchFamily="34" charset="-122"/>
                 <a:cs typeface="Cambria" pitchFamily="34" charset="-120"/>
               </a:rPr>
-              <a:t>16.7</a:t>
+              <a:t>19.7</a:t>
             </a:r>
             <a:pPr indent="0" marL="0">
               <a:buNone/>
@@ -3276,7 +3276,7 @@
                 <a:ea typeface="Calibri" pitchFamily="34" charset="-122"/>
                 <a:cs typeface="Calibri" pitchFamily="34" charset="-120"/>
               </a:rPr>
-              <a:t>projected  23.3</a:t>
+              <a:t>was 16.3 · recall 5 of 6</a:t>
             </a:r>
             <a:endParaRPr lang="en-US" sz="1000" dirty="0"/>
           </a:p>
@@ -3375,13 +3375,13 @@
             <a:r>
               <a:rPr lang="en-US" sz="3000" b="1" dirty="0">
                 <a:solidFill>
-                  <a:srgbClr val="F2A63B"/>
+                  <a:srgbClr val="5FCB8E"/>
                 </a:solidFill>
                 <a:latin typeface="Cambria" pitchFamily="34" charset="0"/>
                 <a:ea typeface="Cambria" pitchFamily="34" charset="-122"/>
                 <a:cs typeface="Cambria" pitchFamily="34" charset="-120"/>
               </a:rPr>
-              <a:t>46.2</a:t>
+              <a:t>61.8</a:t>
             </a:r>
             <a:pPr indent="0" marL="0">
               <a:buNone/>
@@ -3434,7 +3434,7 @@
                 <a:ea typeface="Calibri" pitchFamily="34" charset="-122"/>
                 <a:cs typeface="Calibri" pitchFamily="34" charset="-120"/>
               </a:rPr>
-              <a:t>projected  62.0</a:t>
+              <a:t>2nd place · started at 37.2</a:t>
             </a:r>
             <a:endParaRPr lang="en-US" sz="1000" dirty="0"/>
           </a:p>
@@ -3539,7 +3539,7 @@
                 <a:ea typeface="Calibri" pitchFamily="34" charset="-122"/>
                 <a:cs typeface="Calibri" pitchFamily="34" charset="-120"/>
               </a:rPr>
-              <a:t>Collection-fingerprint class prior</a:t>
+              <a:t>Silencing the normal Level-2 video we never spotted</a:t>
             </a:r>
             <a:endParaRPr lang="en-US" sz="1050" dirty="0"/>
           </a:p>
@@ -3578,7 +3578,7 @@
                 <a:ea typeface="Calibri" pitchFamily="34" charset="-122"/>
                 <a:cs typeface="Calibri" pitchFamily="34" charset="-120"/>
               </a:rPr>
-              <a:t>37.2 → 46.2</a:t>
+              <a:t>D2 16.1 → 27.6</a:t>
             </a:r>
             <a:endParaRPr lang="en-US" sz="1100" dirty="0"/>
           </a:p>
@@ -3656,7 +3656,7 @@
                 <a:ea typeface="Calibri" pitchFamily="34" charset="-122"/>
                 <a:cs typeface="Calibri" pitchFamily="34" charset="-120"/>
               </a:rPr>
-              <a:t>+8.5 proj.</a:t>
+              <a:t>D3 16.3 → 19.7</a:t>
             </a:r>
             <a:endParaRPr lang="en-US" sz="1100" dirty="0"/>
           </a:p>
@@ -3695,7 +3695,7 @@
                 <a:ea typeface="Calibri" pitchFamily="34" charset="-122"/>
                 <a:cs typeface="Calibri" pitchFamily="34" charset="-120"/>
               </a:rPr>
-              <a:t>Level 1 cut at the F1 break-even p &gt; F1/2</a:t>
+              <a:t>Level 1 with no confidence gate at all</a:t>
             </a:r>
             <a:endParaRPr lang="en-US" sz="1050" dirty="0"/>
           </a:p>
@@ -3734,7 +3734,7 @@
                 <a:ea typeface="Calibri" pitchFamily="34" charset="-122"/>
                 <a:cs typeface="Calibri" pitchFamily="34" charset="-120"/>
               </a:rPr>
-              <a:t>+4.7 proj.</a:t>
+              <a:t>D1 11.8 → 14.5</a:t>
             </a:r>
             <a:endParaRPr lang="en-US" sz="1100" dirty="0"/>
           </a:p>
@@ -3773,7 +3773,7 @@
                 <a:ea typeface="Calibri" pitchFamily="34" charset="-122"/>
                 <a:cs typeface="Calibri" pitchFamily="34" charset="-120"/>
               </a:rPr>
-              <a:t>Raising the Level-1 threshold to 0.7</a:t>
+              <a:t>Collection-fingerprint class prior</a:t>
             </a:r>
             <a:endParaRPr lang="en-US" sz="1050" dirty="0"/>
           </a:p>
@@ -3806,13 +3806,13 @@
             <a:r>
               <a:rPr lang="en-US" sz="1100" b="1" dirty="0">
                 <a:solidFill>
-                  <a:srgbClr val="E2685F"/>
-                </a:solidFill>
-                <a:latin typeface="Calibri" pitchFamily="34" charset="0"/>
-                <a:ea typeface="Calibri" pitchFamily="34" charset="-122"/>
-                <a:cs typeface="Calibri" pitchFamily="34" charset="-120"/>
-              </a:rPr>
-              <a:t>−2.0</a:t>
+                  <a:srgbClr val="5FCB8E"/>
+                </a:solidFill>
+                <a:latin typeface="Calibri" pitchFamily="34" charset="0"/>
+                <a:ea typeface="Calibri" pitchFamily="34" charset="-122"/>
+                <a:cs typeface="Calibri" pitchFamily="34" charset="-120"/>
+              </a:rPr>
+              <a:t>37.2 → 46.2</a:t>
             </a:r>
             <a:endParaRPr lang="en-US" sz="1100" dirty="0"/>
           </a:p>
@@ -3851,7 +3851,7 @@
                 <a:ea typeface="Calibri" pitchFamily="34" charset="-122"/>
                 <a:cs typeface="Calibri" pitchFamily="34" charset="-120"/>
               </a:rPr>
-              <a:t>Stage B VLM — Qwen3-VL 2B and 4B zero-shot</a:t>
+              <a:t>Raising the Level-1 threshold to 0.7</a:t>
             </a:r>
             <a:endParaRPr lang="en-US" sz="1050" dirty="0"/>
           </a:p>
@@ -3890,7 +3890,7 @@
                 <a:ea typeface="Calibri" pitchFamily="34" charset="-122"/>
                 <a:cs typeface="Calibri" pitchFamily="34" charset="-120"/>
               </a:rPr>
-              <a:t>−3.7</a:t>
+              <a:t>−2.0</a:t>
             </a:r>
             <a:endParaRPr lang="en-US" sz="1100" dirty="0"/>
           </a:p>
@@ -4073,7 +4073,7 @@
                 <a:ea typeface="Calibri" pitchFamily="34" charset="-122"/>
                 <a:cs typeface="Calibri" pitchFamily="34" charset="-120"/>
               </a:rPr>
-              <a:t>The encoding profile leaks the class.</a:t>
+              <a:t>We were scoring a formula we had invented.</a:t>
             </a:r>
             <a:endParaRPr lang="en-US" sz="1100" dirty="0"/>
           </a:p>
@@ -4115,7 +4115,7 @@
                 <a:ea typeface="Calibri" pitchFamily="34" charset="-122"/>
                 <a:cs typeface="Calibri" pitchFamily="34" charset="-120"/>
               </a:rPr>
-              <a:t>(width, height, fps) identifies the source collection, and the public ground truth says what each contains. It predicts E024 is normal, which upload deltas had already proved independently, and it showed the L2 collection is composed on a 5 s grid — T025 is six events at 20+40i.</a:t>
+              <a:t>A scorer fitted to the practice pack said Level 1 was F1-based, so we kept tightening a confidence gate. The leaderboard prints “found x/17”, which fixes the denominator and restores the documented rule: half the marks are binary accuracy and 17 of 20 clips carry an event, so there is no precision penalty at all. Deleting the gate was worth +2.7.</a:t>
             </a:r>
             <a:endParaRPr lang="en-US" sz="850" dirty="0"/>
           </a:p>
@@ -4154,7 +4154,7 @@
                 <a:ea typeface="Calibri" pitchFamily="34" charset="-122"/>
                 <a:cs typeface="Calibri" pitchFamily="34" charset="-120"/>
               </a:rPr>
-              <a:t>Proposals are solved; ranking is not.</a:t>
+              <a:t>A normal video is worth a whole video.</a:t>
             </a:r>
             <a:endParaRPr lang="en-US" sz="1100" dirty="0"/>
           </a:p>
@@ -4196,7 +4196,7 @@
                 <a:ea typeface="Calibri" pitchFamily="34" charset="-122"/>
                 <a:cs typeface="Calibri" pitchFamily="34" charset="-120"/>
               </a:rPr>
-              <a:t>A 2.5 s lattice covers 100% of public truths at IoU 0.5. But the head’s anomaly curve is saturated at exactly 1.0000, zero variance, on three private videos, and twelve replacement scores all reach 0% recall@128 on Level 3.</a:t>
+              <a:t>A rival submitted nothing on Level 2 and scored exactly 17.5 of 35 — one half, so two of its four videos are normal. We had carried events on both candidates in every upload, taking a guaranteed zero on one. Silencing the right one was worth +11.5, our single largest gain.</a:t>
             </a:r>
             <a:endParaRPr lang="en-US" sz="850" dirty="0"/>
           </a:p>
@@ -4235,7 +4235,7 @@
                 <a:ea typeface="Calibri" pitchFamily="34" charset="-122"/>
                 <a:cs typeface="Calibri" pitchFamily="34" charset="-120"/>
               </a:rPr>
-              <a:t>The leaderboard is a measuring instrument.</a:t>
+              <a:t>Proposals are solved; ranking is not.</a:t>
             </a:r>
             <a:endParaRPr lang="en-US" sz="1100" dirty="0"/>
           </a:p>
@@ -4277,7 +4277,7 @@
                 <a:ea typeface="Calibri" pitchFamily="34" charset="-122"/>
                 <a:cs typeface="Calibri" pitchFamily="34" charset="-120"/>
               </a:rPr>
-              <a:t>Eight uploads and no ground truth pinned the alert weight at 0.20, proved all four L3 videos anomalous, and recovered 35 ground-truth events plus the four classes we never find — from per-class false-alarm counts alone.</a:t>
+              <a:t>A 2.5 s lattice covers 100% of public truths at IoU 0.5 and our recall now leads the field. But the head’s anomaly curve is saturated at exactly 1.0000, zero variance, on three private videos, and twelve replacement scores all reach 0% recall@128 on Level 3.</a:t>
             </a:r>
             <a:endParaRPr lang="en-US" sz="850" dirty="0"/>
           </a:p>
@@ -4316,7 +4316,7 @@
                 <a:ea typeface="Calibri" pitchFamily="34" charset="-122"/>
                 <a:cs typeface="Calibri" pitchFamily="34" charset="-120"/>
               </a:rPr>
-              <a:t>Negative results reported deliberately: zero-shot Qwen3-VL scored 0/4 (2B) and 1/6 (4B) on segments the 2.18M head got 3/6 right, at 7.4× the latency. We kept what the measurements supported, not what we expected.</a:t>
+              <a:t>Where the marks still are: we hold the highest recall in the field at both temporal difficulties — 5 of 6 at Level 3, 5 of 12 at Level 2 — and convert the least of it, because we cannot say which of our candidates are the right ones. That one gap is worth about thirteen marks.</a:t>
             </a:r>
             <a:endParaRPr lang="en-US" sz="1100" dirty="0"/>
           </a:p>

</xml_diff>